<commit_message>
Fix presentation evidence generation
Co-authored-by: Sho-sai <56021664+Sho-sai@users.noreply.github.com>
</commit_message>
<xml_diff>
--- a/presentations/M365_Copilot_License_Expansion_ISD_Strategy_20260916.pptx
+++ b/presentations/M365_Copilot_License_Expansion_ISD_Strategy_20260916.pptx
@@ -8515,7 +8515,7 @@
               </a:defRPr>
             </a:pPr>
             <a:r>
-              <a:t>JP  |  資料内日付: 2026/09  |  判断: 営業優先  |  根拠信頼度: 高</a:t>
+              <a:t>JP  |  資料内日付: 2026/07  |  判断: 営業優先  |  根拠信頼度: 高</a:t>
             </a:r>
           </a:p>
         </p:txBody>
@@ -14333,7 +14333,7 @@
               </a:defRPr>
             </a:pPr>
             <a:r>
-              <a:t>JP  |  資料内日付: 2026/09  |  判断: 条件付き  |  根拠信頼度: 中</a:t>
+              <a:t>JP  |  資料内日付: 2026/07  |  判断: 条件付き  |  根拠信頼度: 中</a:t>
             </a:r>
           </a:p>
         </p:txBody>
@@ -15431,7 +15431,7 @@
               </a:defRPr>
             </a:pPr>
             <a:r>
-              <a:t>JP  |  資料内日付: 2026/09  |  判断: 営業優先  |  根拠信頼度: 中</a:t>
+              <a:t>JP  |  資料内日付: 2026/07  |  判断: 営業優先  |  根拠信頼度: 中</a:t>
             </a:r>
           </a:p>
         </p:txBody>
@@ -15980,7 +15980,7 @@
               </a:defRPr>
             </a:pPr>
             <a:r>
-              <a:t>JP  |  資料内日付: 2026/09  |  判断: 要確認  |  根拠信頼度: 低</a:t>
+              <a:t>JP  |  資料内日付: 2026/07  |  判断: 要確認  |  根拠信頼度: 低</a:t>
             </a:r>
           </a:p>
         </p:txBody>
@@ -16529,7 +16529,7 @@
               </a:defRPr>
             </a:pPr>
             <a:r>
-              <a:t>JP  |  資料内日付: 2026/09  |  判断: 要確認  |  根拠信頼度: 低</a:t>
+              <a:t>JP  |  資料内日付: 2026/07  |  判断: 要確認  |  根拠信頼度: 低</a:t>
             </a:r>
           </a:p>
         </p:txBody>
@@ -17078,7 +17078,7 @@
               </a:defRPr>
             </a:pPr>
             <a:r>
-              <a:t>JP  |  資料内日付: 2026/09  |  判断: 要確認  |  根拠信頼度: 低</a:t>
+              <a:t>JP  |  資料内日付: 2026/07  |  判断: 要確認  |  根拠信頼度: 低</a:t>
             </a:r>
           </a:p>
         </p:txBody>
@@ -17955,7 +17955,7 @@
               </a:defRPr>
             </a:pPr>
             <a:r>
-              <a:t>JP  |  資料内日付: 2026/09  |  判断: 要確認  |  根拠信頼度: 低</a:t>
+              <a:t>JP  |  資料内日付: 2026/07  |  判断: 要確認  |  根拠信頼度: 低</a:t>
             </a:r>
           </a:p>
         </p:txBody>
@@ -18504,7 +18504,7 @@
               </a:defRPr>
             </a:pPr>
             <a:r>
-              <a:t>JP  |  資料内日付: 2026/09  |  判断: 要確認  |  根拠信頼度: 低</a:t>
+              <a:t>JP  |  資料内日付: 2026/07  |  判断: 要確認  |  根拠信頼度: 低</a:t>
             </a:r>
           </a:p>
         </p:txBody>
@@ -19053,7 +19053,7 @@
               </a:defRPr>
             </a:pPr>
             <a:r>
-              <a:t>JP  |  資料内日付: 2026/09  |  判断: 要確認  |  根拠信頼度: 低</a:t>
+              <a:t>JP  |  資料内日付: 2026/07  |  判断: 要確認  |  根拠信頼度: 低</a:t>
             </a:r>
           </a:p>
         </p:txBody>
@@ -19602,7 +19602,7 @@
               </a:defRPr>
             </a:pPr>
             <a:r>
-              <a:t>JP  |  資料内日付: 2026/09  |  判断: 営業優先  |  根拠信頼度: 高</a:t>
+              <a:t>JP  |  資料内日付: 2026/07  |  判断: 営業優先  |  根拠信頼度: 高</a:t>
             </a:r>
           </a:p>
         </p:txBody>
@@ -20151,7 +20151,7 @@
               </a:defRPr>
             </a:pPr>
             <a:r>
-              <a:t>JP  |  資料内日付: 2026/09  |  判断: 営業優先  |  根拠信頼度: 中</a:t>
+              <a:t>JP  |  資料内日付: 2026/07  |  判断: 営業優先  |  根拠信頼度: 中</a:t>
             </a:r>
           </a:p>
         </p:txBody>
@@ -20700,7 +20700,7 @@
               </a:defRPr>
             </a:pPr>
             <a:r>
-              <a:t>JP  |  資料内日付: 2026/09  |  判断: 要確認  |  根拠信頼度: 低</a:t>
+              <a:t>JP  |  資料内日付: 2026/07  |  判断: 要確認  |  根拠信頼度: 低</a:t>
             </a:r>
           </a:p>
         </p:txBody>
@@ -21249,7 +21249,7 @@
               </a:defRPr>
             </a:pPr>
             <a:r>
-              <a:t>JP  |  資料内日付: 2026/09  |  判断: 営業優先  |  根拠信頼度: 中</a:t>
+              <a:t>JP  |  資料内日付: 2026/07  |  判断: 営業優先  |  根拠信頼度: 中</a:t>
             </a:r>
           </a:p>
         </p:txBody>
@@ -21798,7 +21798,7 @@
               </a:defRPr>
             </a:pPr>
             <a:r>
-              <a:t>JP  |  資料内日付: 2026/09  |  判断: 要確認  |  根拠信頼度: 低</a:t>
+              <a:t>JP  |  資料内日付: 2026/07  |  判断: 要確認  |  根拠信頼度: 低</a:t>
             </a:r>
           </a:p>
         </p:txBody>
@@ -22347,7 +22347,7 @@
               </a:defRPr>
             </a:pPr>
             <a:r>
-              <a:t>JP  |  資料内日付: 2026/09  |  判断: 要確認  |  根拠信頼度: 低</a:t>
+              <a:t>JP  |  資料内日付: 2026/07  |  判断: 要確認  |  根拠信頼度: 低</a:t>
             </a:r>
           </a:p>
         </p:txBody>
@@ -25420,7 +25420,7 @@
               </a:defRPr>
             </a:pPr>
             <a:r>
-              <a:t>Americas  |  資料内日付: 2026/09  |  判断: 要確認  |  根拠信頼度: 低</a:t>
+              <a:t>Americas  |  資料内日付: 2026/07  |  判断: 要確認  |  根拠信頼度: 低</a:t>
             </a:r>
           </a:p>
         </p:txBody>
@@ -25969,7 +25969,7 @@
               </a:defRPr>
             </a:pPr>
             <a:r>
-              <a:t>Americas  |  資料内日付: 2026/09  |  判断: 要確認  |  根拠信頼度: 低</a:t>
+              <a:t>Americas  |  資料内日付: 2026/07  |  判断: 要確認  |  根拠信頼度: 低</a:t>
             </a:r>
           </a:p>
         </p:txBody>
@@ -26518,7 +26518,7 @@
               </a:defRPr>
             </a:pPr>
             <a:r>
-              <a:t>Americas  |  資料内日付: 2026/09  |  判断: 要確認  |  根拠信頼度: 低</a:t>
+              <a:t>Americas  |  資料内日付: 2026/07  |  判断: 要確認  |  根拠信頼度: 低</a:t>
             </a:r>
           </a:p>
         </p:txBody>
@@ -27067,7 +27067,7 @@
               </a:defRPr>
             </a:pPr>
             <a:r>
-              <a:t>Americas  |  資料内日付: 2026/09  |  判断: 要確認  |  根拠信頼度: 低</a:t>
+              <a:t>Americas  |  資料内日付: 2026/07  |  判断: 要確認  |  根拠信頼度: 低</a:t>
             </a:r>
           </a:p>
         </p:txBody>
@@ -27616,7 +27616,7 @@
               </a:defRPr>
             </a:pPr>
             <a:r>
-              <a:t>Americas  |  資料内日付: 2026/09  |  判断: 要確認  |  根拠信頼度: 低</a:t>
+              <a:t>Americas  |  資料内日付: 2026/07  |  判断: 要確認  |  根拠信頼度: 低</a:t>
             </a:r>
           </a:p>
         </p:txBody>
@@ -28165,7 +28165,7 @@
               </a:defRPr>
             </a:pPr>
             <a:r>
-              <a:t>Americas  |  資料内日付: 2026/09  |  判断: 要確認  |  根拠信頼度: 低</a:t>
+              <a:t>Americas  |  資料内日付: 2026/07  |  判断: 要確認  |  根拠信頼度: 低</a:t>
             </a:r>
           </a:p>
         </p:txBody>
@@ -28714,7 +28714,7 @@
               </a:defRPr>
             </a:pPr>
             <a:r>
-              <a:t>Americas  |  資料内日付: 2026/09  |  判断: 要確認  |  根拠信頼度: 低</a:t>
+              <a:t>Americas  |  資料内日付: 2026/07  |  判断: 要確認  |  根拠信頼度: 低</a:t>
             </a:r>
           </a:p>
         </p:txBody>
@@ -29591,7 +29591,7 @@
               </a:defRPr>
             </a:pPr>
             <a:r>
-              <a:t>Americas  |  資料内日付: 2026/09  |  判断: 要確認  |  根拠信頼度: 低</a:t>
+              <a:t>Americas  |  資料内日付: 2026/07  |  判断: 要確認  |  根拠信頼度: 低</a:t>
             </a:r>
           </a:p>
         </p:txBody>
@@ -30140,7 +30140,7 @@
               </a:defRPr>
             </a:pPr>
             <a:r>
-              <a:t>Americas  |  資料内日付: 2026/09  |  判断: 要確認  |  根拠信頼度: 低</a:t>
+              <a:t>Americas  |  資料内日付: 2026/07  |  判断: 要確認  |  根拠信頼度: 低</a:t>
             </a:r>
           </a:p>
         </p:txBody>
@@ -30689,7 +30689,7 @@
               </a:defRPr>
             </a:pPr>
             <a:r>
-              <a:t>Americas  |  資料内日付: 2026/09  |  判断: 要確認  |  根拠信頼度: 低</a:t>
+              <a:t>Americas  |  資料内日付: 2026/07  |  判断: 要確認  |  根拠信頼度: 低</a:t>
             </a:r>
           </a:p>
         </p:txBody>
@@ -31238,7 +31238,7 @@
               </a:defRPr>
             </a:pPr>
             <a:r>
-              <a:t>Americas  |  資料内日付: 2026/09  |  判断: 要確認  |  根拠信頼度: 低</a:t>
+              <a:t>Americas  |  資料内日付: 2026/07  |  判断: 要確認  |  根拠信頼度: 低</a:t>
             </a:r>
           </a:p>
         </p:txBody>
@@ -31787,7 +31787,7 @@
               </a:defRPr>
             </a:pPr>
             <a:r>
-              <a:t>Americas  |  資料内日付: 2026/09  |  判断: 要確認  |  根拠信頼度: 低</a:t>
+              <a:t>Americas  |  資料内日付: 2026/07  |  判断: 要確認  |  根拠信頼度: 低</a:t>
             </a:r>
           </a:p>
         </p:txBody>
@@ -32336,7 +32336,7 @@
               </a:defRPr>
             </a:pPr>
             <a:r>
-              <a:t>Americas  |  資料内日付: 2026/09  |  判断: 要確認  |  根拠信頼度: 低</a:t>
+              <a:t>Americas  |  資料内日付: 2026/07  |  判断: 要確認  |  根拠信頼度: 低</a:t>
             </a:r>
           </a:p>
         </p:txBody>
@@ -32885,7 +32885,7 @@
               </a:defRPr>
             </a:pPr>
             <a:r>
-              <a:t>Americas  |  資料内日付: 2026/09  |  判断: 要確認  |  根拠信頼度: 低</a:t>
+              <a:t>Americas  |  資料内日付: 2026/07  |  判断: 要確認  |  根拠信頼度: 低</a:t>
             </a:r>
           </a:p>
         </p:txBody>
@@ -33434,7 +33434,7 @@
               </a:defRPr>
             </a:pPr>
             <a:r>
-              <a:t>Americas  |  資料内日付: 2026/09  |  判断: 要確認  |  根拠信頼度: 低</a:t>
+              <a:t>Americas  |  資料内日付: 2026/07  |  判断: 要確認  |  根拠信頼度: 低</a:t>
             </a:r>
           </a:p>
         </p:txBody>
@@ -36507,7 +36507,7 @@
               </a:defRPr>
             </a:pPr>
             <a:r>
-              <a:t>EMEA  |  資料内日付: 2026/09  |  判断: 要確認  |  根拠信頼度: 低</a:t>
+              <a:t>EMEA  |  資料内日付: 2026/07  |  判断: 要確認  |  根拠信頼度: 低</a:t>
             </a:r>
           </a:p>
         </p:txBody>

</xml_diff>

<commit_message>
Refine presentation generation checks
Co-authored-by: Sho-sai <56021664+Sho-sai@users.noreply.github.com>
</commit_message>
<xml_diff>
--- a/presentations/M365_Copilot_License_Expansion_ISD_Strategy_20260916.pptx
+++ b/presentations/M365_Copilot_License_Expansion_ISD_Strategy_20260916.pptx
@@ -3267,7 +3267,7 @@
               </a:defRPr>
             </a:pPr>
             <a:r>
-              <a:t>2026年09月16日｜52アカウントの資料統合｜顧客内部情報を含む／取扱注意</a:t>
+              <a:t>2026年9月16日｜52アカウントの資料統合｜顧客内部情報を含む／取扱注意</a:t>
             </a:r>
           </a:p>
         </p:txBody>
@@ -3322,7 +3322,7 @@
               </a:defRPr>
             </a:pPr>
             <a:r>
-              <a:t>分析・推薦（資料記載と区別）  |  2026年09月16日  |  顧客内部情報を含む／取扱注意</a:t>
+              <a:t>分析・推薦（資料記載と区別）  |  2026年9月16日  |  顧客内部情報を含む／取扱注意</a:t>
             </a:r>
           </a:p>
         </p:txBody>
@@ -3650,7 +3650,7 @@
               </a:defRPr>
             </a:pPr>
             <a:r>
-              <a:t>分析・推薦（資料記載と区別）  |  2026年09月16日  |  顧客内部情報を含む／取扱注意</a:t>
+              <a:t>分析・推薦（資料記載と区別）  |  2026年9月16日  |  顧客内部情報を含む／取扱注意</a:t>
             </a:r>
           </a:p>
         </p:txBody>
@@ -3978,7 +3978,7 @@
               </a:defRPr>
             </a:pPr>
             <a:r>
-              <a:t>分析・推薦（資料記載と区別）  |  2026年09月16日  |  顧客内部情報を含む／取扱注意</a:t>
+              <a:t>分析・推薦（資料記載と区別）  |  2026年9月16日  |  顧客内部情報を含む／取扱注意</a:t>
             </a:r>
           </a:p>
         </p:txBody>
@@ -4306,7 +4306,7 @@
               </a:defRPr>
             </a:pPr>
             <a:r>
-              <a:t>分析・推薦（資料記載と区別）  |  2026年09月16日  |  顧客内部情報を含む／取扱注意</a:t>
+              <a:t>分析・推薦（資料記載と区別）  |  2026年9月16日  |  顧客内部情報を含む／取扱注意</a:t>
             </a:r>
           </a:p>
         </p:txBody>
@@ -4634,7 +4634,7 @@
               </a:defRPr>
             </a:pPr>
             <a:r>
-              <a:t>分析・推薦（資料記載と区別）  |  2026年09月16日  |  顧客内部情報を含む／取扱注意</a:t>
+              <a:t>分析・推薦（資料記載と区別）  |  2026年9月16日  |  顧客内部情報を含む／取扱注意</a:t>
             </a:r>
           </a:p>
         </p:txBody>
@@ -4962,7 +4962,7 @@
               </a:defRPr>
             </a:pPr>
             <a:r>
-              <a:t>分析・推薦（資料記載と区別）  |  2026年09月16日  |  顧客内部情報を含む／取扱注意</a:t>
+              <a:t>分析・推薦（資料記載と区別）  |  2026年9月16日  |  顧客内部情報を含む／取扱注意</a:t>
             </a:r>
           </a:p>
         </p:txBody>
@@ -5290,7 +5290,7 @@
               </a:defRPr>
             </a:pPr>
             <a:r>
-              <a:t>分析・推薦（資料記載と区別）  |  2026年09月16日  |  顧客内部情報を含む／取扱注意</a:t>
+              <a:t>分析・推薦（資料記載と区別）  |  2026年9月16日  |  顧客内部情報を含む／取扱注意</a:t>
             </a:r>
           </a:p>
         </p:txBody>
@@ -5618,7 +5618,7 @@
               </a:defRPr>
             </a:pPr>
             <a:r>
-              <a:t>分析・推薦（資料記載と区別）  |  2026年09月16日  |  顧客内部情報を含む／取扱注意</a:t>
+              <a:t>分析・推薦（資料記載と区別）  |  2026年9月16日  |  顧客内部情報を含む／取扱注意</a:t>
             </a:r>
           </a:p>
         </p:txBody>
@@ -5946,7 +5946,7 @@
               </a:defRPr>
             </a:pPr>
             <a:r>
-              <a:t>分析・推薦（資料記載と区別）  |  2026年09月16日  |  顧客内部情報を含む／取扱注意</a:t>
+              <a:t>分析・推薦（資料記載と区別）  |  2026年9月16日  |  顧客内部情報を含む／取扱注意</a:t>
             </a:r>
           </a:p>
         </p:txBody>
@@ -6274,7 +6274,7 @@
               </a:defRPr>
             </a:pPr>
             <a:r>
-              <a:t>分析・推薦（資料記載と区別）  |  2026年09月16日  |  顧客内部情報を含む／取扱注意</a:t>
+              <a:t>分析・推薦（資料記載と区別）  |  2026年9月16日  |  顧客内部情報を含む／取扱注意</a:t>
             </a:r>
           </a:p>
         </p:txBody>
@@ -6602,7 +6602,7 @@
               </a:defRPr>
             </a:pPr>
             <a:r>
-              <a:t>分析・推薦（資料記載と区別）  |  2026年09月16日  |  顧客内部情報を含む／取扱注意</a:t>
+              <a:t>分析・推薦（資料記載と区別）  |  2026年9月16日  |  顧客内部情報を含む／取扱注意</a:t>
             </a:r>
           </a:p>
         </p:txBody>
@@ -6930,7 +6930,7 @@
               </a:defRPr>
             </a:pPr>
             <a:r>
-              <a:t>分析・推薦（資料記載と区別）  |  2026年09月16日  |  顧客内部情報を含む／取扱注意</a:t>
+              <a:t>分析・推薦（資料記載と区別）  |  2026年9月16日  |  顧客内部情報を含む／取扱注意</a:t>
             </a:r>
           </a:p>
         </p:txBody>
@@ -7258,7 +7258,7 @@
               </a:defRPr>
             </a:pPr>
             <a:r>
-              <a:t>分析・推薦（資料記載と区別）  |  2026年09月16日  |  顧客内部情報を含む／取扱注意</a:t>
+              <a:t>分析・推薦（資料記載と区別）  |  2026年9月16日  |  顧客内部情報を含む／取扱注意</a:t>
             </a:r>
           </a:p>
         </p:txBody>
@@ -7586,7 +7586,7 @@
               </a:defRPr>
             </a:pPr>
             <a:r>
-              <a:t>分析・推薦（資料記載と区別）  |  2026年09月16日  |  顧客内部情報を含む／取扱注意</a:t>
+              <a:t>分析・推薦（資料記載と区別）  |  2026年9月16日  |  顧客内部情報を含む／取扱注意</a:t>
             </a:r>
           </a:p>
         </p:txBody>
@@ -7914,7 +7914,7 @@
               </a:defRPr>
             </a:pPr>
             <a:r>
-              <a:t>分析・推薦（資料記載と区別）  |  2026年09月16日  |  顧客内部情報を含む／取扱注意</a:t>
+              <a:t>分析・推薦（資料記載と区別）  |  2026年9月16日  |  顧客内部情報を含む／取扱注意</a:t>
             </a:r>
           </a:p>
         </p:txBody>
@@ -8242,7 +8242,7 @@
               </a:defRPr>
             </a:pPr>
             <a:r>
-              <a:t>分析・推薦（資料記載と区別）  |  2026年09月16日  |  顧客内部情報を含む／取扱注意</a:t>
+              <a:t>分析・推薦（資料記載と区別）  |  2026年9月16日  |  顧客内部情報を含む／取扱注意</a:t>
             </a:r>
           </a:p>
         </p:txBody>
@@ -8570,7 +8570,7 @@
               </a:defRPr>
             </a:pPr>
             <a:r>
-              <a:t>docs/01_トヨタ自動車 TMC.md:16–20（GitHub commit は source_manifest.json を参照）  |  2026年09月16日  |  顧客内部情報を含む／取扱注意</a:t>
+              <a:t>docs/01_トヨタ自動車 TMC.md:16–20（GitHub commit は source_manifest.json を参照）  |  2026年9月16日  |  顧客内部情報を含む／取扱注意</a:t>
             </a:r>
           </a:p>
         </p:txBody>
@@ -9119,7 +9119,7 @@
               </a:defRPr>
             </a:pPr>
             <a:r>
-              <a:t>docs/02_DENSO 本体.md:14–16（GitHub commit は source_manifest.json を参照）  |  2026年09月16日  |  顧客内部情報を含む／取扱注意</a:t>
+              <a:t>docs/02_DENSO 本体.md:14–16（GitHub commit は source_manifest.json を参照）  |  2026年9月16日  |  顧客内部情報を含む／取扱注意</a:t>
             </a:r>
           </a:p>
         </p:txBody>
@@ -9668,7 +9668,7 @@
               </a:defRPr>
             </a:pPr>
             <a:r>
-              <a:t>docs/03_AISIN 本体.md:14–19（GitHub commit は source_manifest.json を参照）  |  2026年09月16日  |  顧客内部情報を含む／取扱注意</a:t>
+              <a:t>docs/03_AISIN 本体.md:14–19（GitHub commit は source_manifest.json を参照）  |  2026年9月16日  |  顧客内部情報を含む／取扱注意</a:t>
             </a:r>
           </a:p>
         </p:txBody>
@@ -10217,7 +10217,7 @@
               </a:defRPr>
             </a:pPr>
             <a:r>
-              <a:t>docs/04_マツダ Mazda.md:16–18（GitHub commit は source_manifest.json を参照）  |  2026年09月16日  |  顧客内部情報を含む／取扱注意</a:t>
+              <a:t>docs/04_マツダ Mazda.md:16–18（GitHub commit は source_manifest.json を参照）  |  2026年9月16日  |  顧客内部情報を含む／取扱注意</a:t>
             </a:r>
           </a:p>
         </p:txBody>
@@ -10766,7 +10766,7 @@
               </a:defRPr>
             </a:pPr>
             <a:r>
-              <a:t>docs/05_スバル Subaru.md:15–17（GitHub commit は source_manifest.json を参照）  |  2026年09月16日  |  顧客内部情報を含む／取扱注意</a:t>
+              <a:t>docs/05_スバル Subaru.md:15–17（GitHub commit は source_manifest.json を参照）  |  2026年9月16日  |  顧客内部情報を含む／取扱注意</a:t>
             </a:r>
           </a:p>
         </p:txBody>
@@ -11315,7 +11315,7 @@
               </a:defRPr>
             </a:pPr>
             <a:r>
-              <a:t>docs/06_豊田通商 TTC.md:15–19（GitHub commit は source_manifest.json を参照）  |  2026年09月16日  |  顧客内部情報を含む／取扱注意</a:t>
+              <a:t>docs/06_豊田通商 TTC.md:15–19（GitHub commit は source_manifest.json を参照）  |  2026年9月16日  |  顧客内部情報を含む／取扱注意</a:t>
             </a:r>
           </a:p>
         </p:txBody>
@@ -11864,7 +11864,7 @@
               </a:defRPr>
             </a:pPr>
             <a:r>
-              <a:t>分析・推薦（資料記載と区別）  |  2026年09月16日  |  顧客内部情報を含む／取扱注意</a:t>
+              <a:t>分析・推薦（資料記載と区別）  |  2026年9月16日  |  顧客内部情報を含む／取扱注意</a:t>
             </a:r>
           </a:p>
         </p:txBody>
@@ -12192,7 +12192,7 @@
               </a:defRPr>
             </a:pPr>
             <a:r>
-              <a:t>docs/07_トヨタ紡織 Toyota Boshoku 本体.md:12–14（GitHub commit は source_manifest.json を参照）  |  2026年09月16日  |  顧客内部情報を含む／取扱注意</a:t>
+              <a:t>docs/07_トヨタ紡織 Toyota Boshoku 本体.md:12–14（GitHub commit は source_manifest.json を参照）  |  2026年9月16日  |  顧客内部情報を含む／取扱注意</a:t>
             </a:r>
           </a:p>
         </p:txBody>
@@ -12741,7 +12741,7 @@
               </a:defRPr>
             </a:pPr>
             <a:r>
-              <a:t>docs/08_トヨタ車体 Toyota Shatai.md:15–17（GitHub commit は source_manifest.json を参照）  |  2026年09月16日  |  顧客内部情報を含む／取扱注意</a:t>
+              <a:t>docs/08_トヨタ車体 Toyota Shatai.md:15–17（GitHub commit は source_manifest.json を参照）  |  2026年9月16日  |  顧客内部情報を含む／取扱注意</a:t>
             </a:r>
           </a:p>
         </p:txBody>
@@ -13290,7 +13290,7 @@
               </a:defRPr>
             </a:pPr>
             <a:r>
-              <a:t>docs/09_豊田自動織機 TICO.md:13–15（GitHub commit は source_manifest.json を参照）  |  2026年09月16日  |  顧客内部情報を含む／取扱注意</a:t>
+              <a:t>docs/09_豊田自動織機 TICO.md:13–15（GitHub commit は source_manifest.json を参照）  |  2026年9月16日  |  顧客内部情報を含む／取扱注意</a:t>
             </a:r>
           </a:p>
         </p:txBody>
@@ -13839,7 +13839,7 @@
               </a:defRPr>
             </a:pPr>
             <a:r>
-              <a:t>docs/10_愛三工業.md:20–25（GitHub commit は source_manifest.json を参照）  |  2026年09月16日  |  顧客内部情報を含む／取扱注意</a:t>
+              <a:t>docs/10_愛三工業.md:20–25（GitHub commit は source_manifest.json を参照）  |  2026年9月16日  |  顧客内部情報を含む／取扱注意</a:t>
             </a:r>
           </a:p>
         </p:txBody>
@@ -14388,7 +14388,7 @@
               </a:defRPr>
             </a:pPr>
             <a:r>
-              <a:t>docs/11_トヨタコニックプロ.md:16–16（GitHub commit は source_manifest.json を参照）  |  2026年09月16日  |  顧客内部情報を含む／取扱注意</a:t>
+              <a:t>docs/11_トヨタコニックプロ.md:16–16（GitHub commit は source_manifest.json を参照）  |  2026年9月16日  |  顧客内部情報を含む／取扱注意</a:t>
             </a:r>
           </a:p>
         </p:txBody>
@@ -14937,7 +14937,7 @@
               </a:defRPr>
             </a:pPr>
             <a:r>
-              <a:t>docs/12_ダイハツ.md:15–19（GitHub commit は source_manifest.json を参照）  |  2026年09月16日  |  顧客内部情報を含む／取扱注意</a:t>
+              <a:t>docs/12_ダイハツ.md:15–19（GitHub commit は source_manifest.json を参照）  |  2026年9月16日  |  顧客内部情報を含む／取扱注意</a:t>
             </a:r>
           </a:p>
         </p:txBody>
@@ -15486,7 +15486,7 @@
               </a:defRPr>
             </a:pPr>
             <a:r>
-              <a:t>docs/13_ジェイテクト.md:16–17（GitHub commit は source_manifest.json を参照）  |  2026年09月16日  |  顧客内部情報を含む／取扱注意</a:t>
+              <a:t>docs/13_ジェイテクト.md:16–17（GitHub commit は source_manifest.json を参照）  |  2026年9月16日  |  顧客内部情報を含む／取扱注意</a:t>
             </a:r>
           </a:p>
         </p:txBody>
@@ -16035,7 +16035,7 @@
               </a:defRPr>
             </a:pPr>
             <a:r>
-              <a:t>docs/14_カヤバ.md:16–17（GitHub commit は source_manifest.json を参照）  |  2026年09月16日  |  顧客内部情報を含む／取扱注意</a:t>
+              <a:t>docs/14_カヤバ.md:16–17（GitHub commit は source_manifest.json を参照）  |  2026年9月16日  |  顧客内部情報を含む／取扱注意</a:t>
             </a:r>
           </a:p>
         </p:txBody>
@@ -16584,7 +16584,7 @@
               </a:defRPr>
             </a:pPr>
             <a:r>
-              <a:t>docs/15_トヨタコネクティッド.md:16–16（GitHub commit は source_manifest.json を参照）  |  2026年09月16日  |  顧客内部情報を含む／取扱注意</a:t>
+              <a:t>docs/15_トヨタコネクティッド.md:16–16（GitHub commit は source_manifest.json を参照）  |  2026年9月16日  |  顧客内部情報を含む／取扱注意</a:t>
             </a:r>
           </a:p>
         </p:txBody>
@@ -17133,7 +17133,7 @@
               </a:defRPr>
             </a:pPr>
             <a:r>
-              <a:t>docs/16_トヨタ自動車九州.md:16–17（GitHub commit は source_manifest.json を参照）  |  2026年09月16日  |  顧客内部情報を含む／取扱注意</a:t>
+              <a:t>docs/16_トヨタ自動車九州.md:16–17（GitHub commit は source_manifest.json を参照）  |  2026年9月16日  |  顧客内部情報を含む／取扱注意</a:t>
             </a:r>
           </a:p>
         </p:txBody>
@@ -17682,7 +17682,7 @@
               </a:defRPr>
             </a:pPr>
             <a:r>
-              <a:t>分析・推薦（資料記載と区別）  |  2026年09月16日  |  顧客内部情報を含む／取扱注意</a:t>
+              <a:t>分析・推薦（資料記載と区別）  |  2026年9月16日  |  顧客内部情報を含む／取扱注意</a:t>
             </a:r>
           </a:p>
         </p:txBody>
@@ -18010,7 +18010,7 @@
               </a:defRPr>
             </a:pPr>
             <a:r>
-              <a:t>docs/17_株式会社東海理化.md:16–18（GitHub commit は source_manifest.json を参照）  |  2026年09月16日  |  顧客内部情報を含む／取扱注意</a:t>
+              <a:t>docs/17_株式会社東海理化.md:16–18（GitHub commit は source_manifest.json を参照）  |  2026年9月16日  |  顧客内部情報を含む／取扱注意</a:t>
             </a:r>
           </a:p>
         </p:txBody>
@@ -18559,7 +18559,7 @@
               </a:defRPr>
             </a:pPr>
             <a:r>
-              <a:t>docs/18_プライムプラネットエナジー&amp;ソリューションズ株式会社.md:16–18（GitHub commit は source_manifest.json を参照）  |  2026年09月16日  |  顧客内部情報を含む／取扱注意</a:t>
+              <a:t>docs/18_プライムプラネットエナジー&amp;ソリューションズ株式会社.md:16–18（GitHub commit は source_manifest.json を参照）  |  2026年9月16日  |  顧客内部情報を含む／取扱注意</a:t>
             </a:r>
           </a:p>
         </p:txBody>
@@ -19108,7 +19108,7 @@
               </a:defRPr>
             </a:pPr>
             <a:r>
-              <a:t>docs/19_トヨタ自動車北海道株式会社.md:16–18（GitHub commit は source_manifest.json を参照）  |  2026年09月16日  |  顧客内部情報を含む／取扱注意</a:t>
+              <a:t>docs/19_トヨタ自動車北海道株式会社.md:16–18（GitHub commit は source_manifest.json を参照）  |  2026年9月16日  |  顧客内部情報を含む／取扱注意</a:t>
             </a:r>
           </a:p>
         </p:txBody>
@@ -19657,7 +19657,7 @@
               </a:defRPr>
             </a:pPr>
             <a:r>
-              <a:t>docs/20_トヨタテクニカルディベロップメント株式会社.md:16–18（GitHub commit は source_manifest.json を参照）  |  2026年09月16日  |  顧客内部情報を含む／取扱注意</a:t>
+              <a:t>docs/20_トヨタテクニカルディベロップメント株式会社.md:16–18（GitHub commit は source_manifest.json を参照）  |  2026年9月16日  |  顧客内部情報を含む／取扱注意</a:t>
             </a:r>
           </a:p>
         </p:txBody>
@@ -20206,7 +20206,7 @@
               </a:defRPr>
             </a:pPr>
             <a:r>
-              <a:t>docs/21_トヨタ自動車東日本.md:16–17（GitHub commit は source_manifest.json を参照）  |  2026年09月16日  |  顧客内部情報を含む／取扱注意</a:t>
+              <a:t>docs/21_トヨタ自動車東日本.md:16–17（GitHub commit は source_manifest.json を参照）  |  2026年9月16日  |  顧客内部情報を含む／取扱注意</a:t>
             </a:r>
           </a:p>
         </p:txBody>
@@ -20755,7 +20755,7 @@
               </a:defRPr>
             </a:pPr>
             <a:r>
-              <a:t>docs/22_トヨタ不動産.md:16–16（GitHub commit は source_manifest.json を参照）  |  2026年09月16日  |  顧客内部情報を含む／取扱注意</a:t>
+              <a:t>docs/22_トヨタ不動産.md:16–16（GitHub commit は source_manifest.json を参照）  |  2026年9月16日  |  顧客内部情報を含む／取扱注意</a:t>
             </a:r>
           </a:p>
         </p:txBody>
@@ -21304,7 +21304,7 @@
               </a:defRPr>
             </a:pPr>
             <a:r>
-              <a:t>docs/23_トヨタファイナンス.md:16–19（GitHub commit は source_manifest.json を参照）  |  2026年09月16日  |  顧客内部情報を含む／取扱注意</a:t>
+              <a:t>docs/23_トヨタファイナンス.md:16–19（GitHub commit は source_manifest.json を参照）  |  2026年9月16日  |  顧客内部情報を含む／取扱注意</a:t>
             </a:r>
           </a:p>
         </p:txBody>
@@ -21853,7 +21853,7 @@
               </a:defRPr>
             </a:pPr>
             <a:r>
-              <a:t>docs/24_トヨタホーム.md:16–16（GitHub commit は source_manifest.json を参照）  |  2026年09月16日  |  顧客内部情報を含む／取扱注意</a:t>
+              <a:t>docs/24_トヨタホーム.md:16–16（GitHub commit は source_manifest.json を参照）  |  2026年9月16日  |  顧客内部情報を含む／取扱注意</a:t>
             </a:r>
           </a:p>
         </p:txBody>
@@ -22402,7 +22402,7 @@
               </a:defRPr>
             </a:pPr>
             <a:r>
-              <a:t>docs/25_豊田中央研究所.md:16–16（GitHub commit は source_manifest.json を参照）  |  2026年09月16日  |  顧客内部情報を含む／取扱注意</a:t>
+              <a:t>docs/25_豊田中央研究所.md:16–16（GitHub commit は source_manifest.json を参照）  |  2026年9月16日  |  顧客内部情報を含む／取扱注意</a:t>
             </a:r>
           </a:p>
         </p:txBody>
@@ -22951,7 +22951,7 @@
               </a:defRPr>
             </a:pPr>
             <a:r>
-              <a:t>docs/26_TMNA.md:12–17（GitHub commit は source_manifest.json を参照）  |  2026年09月16日  |  顧客内部情報を含む／取扱注意</a:t>
+              <a:t>docs/26_TMNA.md:12–17（GitHub commit は source_manifest.json を参照）  |  2026年9月16日  |  顧客内部情報を含む／取扱注意</a:t>
             </a:r>
           </a:p>
         </p:txBody>
@@ -23500,7 +23500,7 @@
               </a:defRPr>
             </a:pPr>
             <a:r>
-              <a:t>分析・推薦（資料記載と区別）  |  2026年09月16日  |  顧客内部情報を含む／取扱注意</a:t>
+              <a:t>分析・推薦（資料記載と区別）  |  2026年9月16日  |  顧客内部情報を含む／取扱注意</a:t>
             </a:r>
           </a:p>
         </p:txBody>
@@ -23828,7 +23828,7 @@
               </a:defRPr>
             </a:pPr>
             <a:r>
-              <a:t>docs/27_Aisin World America.md:12–13（GitHub commit は source_manifest.json を参照）  |  2026年09月16日  |  顧客内部情報を含む／取扱注意</a:t>
+              <a:t>docs/27_Aisin World America.md:12–13（GitHub commit は source_manifest.json を参照）  |  2026年9月16日  |  顧客内部情報を含む／取扱注意</a:t>
             </a:r>
           </a:p>
         </p:txBody>
@@ -24377,7 +24377,7 @@
               </a:defRPr>
             </a:pPr>
             <a:r>
-              <a:t>docs/28_TMHNA(TINA).md:12–15（GitHub commit は source_manifest.json を参照）  |  2026年09月16日  |  顧客内部情報を含む／取扱注意</a:t>
+              <a:t>docs/28_TMHNA(TINA).md:12–15（GitHub commit は source_manifest.json を参照）  |  2026年9月16日  |  顧客内部情報を含む／取扱注意</a:t>
             </a:r>
           </a:p>
         </p:txBody>
@@ -24926,7 +24926,7 @@
               </a:defRPr>
             </a:pPr>
             <a:r>
-              <a:t>docs/29_JTEKT.md:12–15（GitHub commit は source_manifest.json を参照）  |  2026年09月16日  |  顧客内部情報を含む／取扱注意</a:t>
+              <a:t>docs/29_JTEKT.md:12–15（GitHub commit は source_manifest.json を参照）  |  2026年9月16日  |  顧客内部情報を含む／取扱注意</a:t>
             </a:r>
           </a:p>
         </p:txBody>
@@ -25475,7 +25475,7 @@
               </a:defRPr>
             </a:pPr>
             <a:r>
-              <a:t>docs/30_SUBARU US.md:16–17（GitHub commit は source_manifest.json を参照）  |  2026年09月16日  |  顧客内部情報を含む／取扱注意</a:t>
+              <a:t>docs/30_SUBARU US.md:16–17（GitHub commit は source_manifest.json を参照）  |  2026年9月16日  |  顧客内部情報を含む／取扱注意</a:t>
             </a:r>
           </a:p>
         </p:txBody>
@@ -26024,7 +26024,7 @@
               </a:defRPr>
             </a:pPr>
             <a:r>
-              <a:t>docs/31_TFS.md:16–16（GitHub commit は source_manifest.json を参照）  |  2026年09月16日  |  顧客内部情報を含む／取扱注意</a:t>
+              <a:t>docs/31_TFS.md:16–16（GitHub commit は source_manifest.json を参照）  |  2026年9月16日  |  顧客内部情報を含む／取扱注意</a:t>
             </a:r>
           </a:p>
         </p:txBody>
@@ -26573,7 +26573,7 @@
               </a:defRPr>
             </a:pPr>
             <a:r>
-              <a:t>docs/32_TMMC.md:16–18（GitHub commit は source_manifest.json を参照）  |  2026年09月16日  |  顧客内部情報を含む／取扱注意</a:t>
+              <a:t>docs/32_TMMC.md:16–18（GitHub commit は source_manifest.json を参照）  |  2026年9月16日  |  顧客内部情報を含む／取扱注意</a:t>
             </a:r>
           </a:p>
         </p:txBody>
@@ -27122,7 +27122,7 @@
               </a:defRPr>
             </a:pPr>
             <a:r>
-              <a:t>docs/33_SIA.md:16–17（GitHub commit は source_manifest.json を参照）  |  2026年09月16日  |  顧客内部情報を含む／取扱注意</a:t>
+              <a:t>docs/33_SIA.md:16–17（GitHub commit は source_manifest.json を参照）  |  2026年9月16日  |  顧客内部情報を含む／取扱注意</a:t>
             </a:r>
           </a:p>
         </p:txBody>
@@ -27671,7 +27671,7 @@
               </a:defRPr>
             </a:pPr>
             <a:r>
-              <a:t>docs/34_SCI.md:16–17（GitHub commit は source_manifest.json を参照）  |  2026年09月16日  |  顧客内部情報を含む／取扱注意</a:t>
+              <a:t>docs/34_SCI.md:16–17（GitHub commit は source_manifest.json を参照）  |  2026年9月16日  |  顧客内部情報を含む／取扱注意</a:t>
             </a:r>
           </a:p>
         </p:txBody>
@@ -28220,7 +28220,7 @@
               </a:defRPr>
             </a:pPr>
             <a:r>
-              <a:t>docs/35_Bastian.md:16–18（GitHub commit は source_manifest.json を参照）  |  2026年09月16日  |  顧客内部情報を含む／取扱注意</a:t>
+              <a:t>docs/35_Bastian.md:16–18（GitHub commit は source_manifest.json を参照）  |  2026年9月16日  |  顧客内部情報を含む／取扱注意</a:t>
             </a:r>
           </a:p>
         </p:txBody>
@@ -28769,7 +28769,7 @@
               </a:defRPr>
             </a:pPr>
             <a:r>
-              <a:t>docs/36_TAI.md:16–17（GitHub commit は source_manifest.json を参照）  |  2026年09月16日  |  顧客内部情報を含む／取扱注意</a:t>
+              <a:t>docs/36_TAI.md:16–17（GitHub commit は source_manifest.json を参照）  |  2026年9月16日  |  顧客内部情報を含む／取扱注意</a:t>
             </a:r>
           </a:p>
         </p:txBody>
@@ -29318,7 +29318,7 @@
               </a:defRPr>
             </a:pPr>
             <a:r>
-              <a:t>分析・推薦（資料記載と区別）  |  2026年09月16日  |  顧客内部情報を含む／取扱注意</a:t>
+              <a:t>分析・推薦（資料記載と区別）  |  2026年9月16日  |  顧客内部情報を含む／取扱注意</a:t>
             </a:r>
           </a:p>
         </p:txBody>
@@ -29646,7 +29646,7 @@
               </a:defRPr>
             </a:pPr>
             <a:r>
-              <a:t>docs/37_TGNA.md:16–18（GitHub commit は source_manifest.json を参照）  |  2026年09月16日  |  顧客内部情報を含む／取扱注意</a:t>
+              <a:t>docs/37_TGNA.md:16–18（GitHub commit は source_manifest.json を参照）  |  2026年9月16日  |  顧客内部情報を含む／取扱注意</a:t>
             </a:r>
           </a:p>
         </p:txBody>
@@ -30195,7 +30195,7 @@
               </a:defRPr>
             </a:pPr>
             <a:r>
-              <a:t>docs/38_Toyota Colombia.md:16–18（GitHub commit は source_manifest.json を参照）  |  2026年09月16日  |  顧客内部情報を含む／取扱注意</a:t>
+              <a:t>docs/38_Toyota Colombia.md:16–18（GitHub commit は source_manifest.json を参照）  |  2026年9月16日  |  顧客内部情報を含む／取扱注意</a:t>
             </a:r>
           </a:p>
         </p:txBody>
@@ -30744,7 +30744,7 @@
               </a:defRPr>
             </a:pPr>
             <a:r>
-              <a:t>docs/39_Carolina Handling.md:16–17（GitHub commit は source_manifest.json を参照）  |  2026年09月16日  |  顧客内部情報を含む／取扱注意</a:t>
+              <a:t>docs/39_Carolina Handling.md:16–17（GitHub commit は source_manifest.json を参照）  |  2026年9月16日  |  顧客内部情報を含む／取扱注意</a:t>
             </a:r>
           </a:p>
         </p:txBody>
@@ -31293,7 +31293,7 @@
               </a:defRPr>
             </a:pPr>
             <a:r>
-              <a:t>docs/40_Abel Womack.md:16–17（GitHub commit は source_manifest.json を参照）  |  2026年09月16日  |  顧客内部情報を含む／取扱注意</a:t>
+              <a:t>docs/40_Abel Womack.md:16–17（GitHub commit は source_manifest.json を参照）  |  2026年9月16日  |  顧客内部情報を含む／取扱注意</a:t>
             </a:r>
           </a:p>
         </p:txBody>
@@ -31842,7 +31842,7 @@
               </a:defRPr>
             </a:pPr>
             <a:r>
-              <a:t>docs/41_NAL.md:16–17（GitHub commit は source_manifest.json を参照）  |  2026年09月16日  |  顧客内部情報を含む／取扱注意</a:t>
+              <a:t>docs/41_NAL.md:16–17（GitHub commit は source_manifest.json を参照）  |  2026年9月16日  |  顧客内部情報を含む／取扱注意</a:t>
             </a:r>
           </a:p>
         </p:txBody>
@@ -32391,7 +32391,7 @@
               </a:defRPr>
             </a:pPr>
             <a:r>
-              <a:t>docs/42_MACI.md:16–17（GitHub commit は source_manifest.json を参照）  |  2026年09月16日  |  顧客内部情報を含む／取扱注意</a:t>
+              <a:t>docs/42_MACI.md:16–17（GitHub commit は source_manifest.json を参照）  |  2026年9月16日  |  顧客内部情報を含む／取扱注意</a:t>
             </a:r>
           </a:p>
         </p:txBody>
@@ -32940,7 +32940,7 @@
               </a:defRPr>
             </a:pPr>
             <a:r>
-              <a:t>docs/43_Cascade.md:16–17（GitHub commit は source_manifest.json を参照）  |  2026年09月16日  |  顧客内部情報を含む／取扱注意</a:t>
+              <a:t>docs/43_Cascade.md:16–17（GitHub commit は source_manifest.json を参照）  |  2026年9月16日  |  顧客内部情報を含む／取扱注意</a:t>
             </a:r>
           </a:p>
         </p:txBody>
@@ -33489,7 +33489,7 @@
               </a:defRPr>
             </a:pPr>
             <a:r>
-              <a:t>docs/44_Shiroki.md:16–17（GitHub commit は source_manifest.json を参照）  |  2026年09月16日  |  顧客内部情報を含む／取扱注意</a:t>
+              <a:t>docs/44_Shiroki.md:16–17（GitHub commit は source_manifest.json を参照）  |  2026年9月16日  |  顧客内部情報を含む／取扱注意</a:t>
             </a:r>
           </a:p>
         </p:txBody>
@@ -34038,7 +34038,7 @@
               </a:defRPr>
             </a:pPr>
             <a:r>
-              <a:t>docs/45_TOYOTA MOTOR EUROPE.md:12–15（GitHub commit は source_manifest.json を参照）  |  2026年09月16日  |  顧客内部情報を含む／取扱注意</a:t>
+              <a:t>docs/45_TOYOTA MOTOR EUROPE.md:12–15（GitHub commit は source_manifest.json を参照）  |  2026年9月16日  |  顧客内部情報を含む／取扱注意</a:t>
             </a:r>
           </a:p>
         </p:txBody>
@@ -34587,7 +34587,7 @@
               </a:defRPr>
             </a:pPr>
             <a:r>
-              <a:t>docs/46_VANDERLANDE.md:12–19（GitHub commit は source_manifest.json を参照）  |  2026年09月16日  |  顧客内部情報を含む／取扱注意</a:t>
+              <a:t>docs/46_VANDERLANDE.md:12–19（GitHub commit は source_manifest.json を参照）  |  2026年9月16日  |  顧客内部情報を含む／取扱注意</a:t>
             </a:r>
           </a:p>
         </p:txBody>
@@ -35136,7 +35136,7 @@
               </a:defRPr>
             </a:pPr>
             <a:r>
-              <a:t>分析・推薦（資料記載と区別）  |  2026年09月16日  |  顧客内部情報を含む／取扱注意</a:t>
+              <a:t>分析・推薦（資料記載と区別）  |  2026年9月16日  |  顧客内部情報を含む／取扱注意</a:t>
             </a:r>
           </a:p>
         </p:txBody>
@@ -35464,7 +35464,7 @@
               </a:defRPr>
             </a:pPr>
             <a:r>
-              <a:t>docs/47_TMHE.md:12–19（GitHub commit は source_manifest.json を参照）  |  2026年09月16日  |  顧客内部情報を含む／取扱注意</a:t>
+              <a:t>docs/47_TMHE.md:12–19（GitHub commit は source_manifest.json を参照）  |  2026年9月16日  |  顧客内部情報を含む／取扱注意</a:t>
             </a:r>
           </a:p>
         </p:txBody>
@@ -36013,7 +36013,7 @@
               </a:defRPr>
             </a:pPr>
             <a:r>
-              <a:t>docs/48_CFAO.md:12–19（GitHub commit は source_manifest.json を参照）  |  2026年09月16日  |  顧客内部情報を含む／取扱注意</a:t>
+              <a:t>docs/48_CFAO.md:12–19（GitHub commit は source_manifest.json を参照）  |  2026年9月16日  |  顧客内部情報を含む／取扱注意</a:t>
             </a:r>
           </a:p>
         </p:txBody>
@@ -36562,7 +36562,7 @@
               </a:defRPr>
             </a:pPr>
             <a:r>
-              <a:t>docs/49_TAL.md:16–17（GitHub commit は source_manifest.json を参照）  |  2026年09月16日  |  顧客内部情報を含む／取扱注意</a:t>
+              <a:t>docs/49_TAL.md:16–17（GitHub commit は source_manifest.json を参照）  |  2026年9月16日  |  顧客内部情報を含む／取扱注意</a:t>
             </a:r>
           </a:p>
         </p:txBody>
@@ -37111,7 +37111,7 @@
               </a:defRPr>
             </a:pPr>
             <a:r>
-              <a:t>docs/50_TFS.md:12–17（GitHub commit は source_manifest.json を参照）  |  2026年09月16日  |  顧客内部情報を含む／取扱注意</a:t>
+              <a:t>docs/50_TFS.md:12–17（GitHub commit は source_manifest.json を参照）  |  2026年9月16日  |  顧客内部情報を含む／取扱注意</a:t>
             </a:r>
           </a:p>
         </p:txBody>
@@ -37660,7 +37660,7 @@
               </a:defRPr>
             </a:pPr>
             <a:r>
-              <a:t>docs/51_TOYOTA MOTOR ASIA.md:15–18（GitHub commit は source_manifest.json を参照）  |  2026年09月16日  |  顧客内部情報を含む／取扱注意</a:t>
+              <a:t>docs/51_TOYOTA MOTOR ASIA.md:15–18（GitHub commit は source_manifest.json を参照）  |  2026年9月16日  |  顧客内部情報を含む／取扱注意</a:t>
             </a:r>
           </a:p>
         </p:txBody>
@@ -38209,7 +38209,7 @@
               </a:defRPr>
             </a:pPr>
             <a:r>
-              <a:t>docs/52_TMCA.md:14–19（GitHub commit は source_manifest.json を参照）  |  2026年09月16日  |  顧客内部情報を含む／取扱注意</a:t>
+              <a:t>docs/52_TMCA.md:14–19（GitHub commit は source_manifest.json を参照）  |  2026年9月16日  |  顧客内部情報を含む／取扱注意</a:t>
             </a:r>
           </a:p>
         </p:txBody>
@@ -38758,7 +38758,7 @@
               </a:defRPr>
             </a:pPr>
             <a:r>
-              <a:t>分析・推薦（資料記載と区別）  |  2026年09月16日  |  顧客内部情報を含む／取扱注意</a:t>
+              <a:t>分析・推薦（資料記載と区別）  |  2026年9月16日  |  顧客内部情報を含む／取扱注意</a:t>
             </a:r>
           </a:p>
         </p:txBody>
@@ -39086,7 +39086,7 @@
               </a:defRPr>
             </a:pPr>
             <a:r>
-              <a:t>分析・推薦（資料記載と区別）  |  2026年09月16日  |  顧客内部情報を含む／取扱注意</a:t>
+              <a:t>分析・推薦（資料記載と区別）  |  2026年9月16日  |  顧客内部情報を含む／取扱注意</a:t>
             </a:r>
           </a:p>
         </p:txBody>

</xml_diff>